<commit_message>
Name origin: Lumi = luminous (deck title slide, README)
Co-Authored-By: Claude Sonnet 5.5 <noreply@anthropic.com>
</commit_message>
<xml_diff>
--- a/docs/hologram-deck.pptx
+++ b/docs/hologram-deck.pptx
@@ -4400,6 +4400,45 @@
         </p:nvSpPr>
         <p:spPr>
           <a:xfrm>
+            <a:off x="731520" y="5074920"/>
+            <a:ext cx="6583680" cy="457200"/>
+          </a:xfrm>
+          <a:prstGeom prst="rect">
+            <a:avLst/>
+          </a:prstGeom>
+          <a:noFill/>
+          <a:ln/>
+        </p:spPr>
+        <p:txBody>
+          <a:bodyPr wrap="square" lIns="0" tIns="0" rIns="0" bIns="0" rtlCol="0" anchor="t"/>
+          <a:lstStyle/>
+          <a:p>
+            <a:pPr indent="0" marL="0">
+              <a:buNone/>
+            </a:pPr>
+            <a:r>
+              <a:rPr lang="en-US" sz="1500" dirty="0">
+                <a:solidFill>
+                  <a:srgbClr val="FCD34D"/>
+                </a:solidFill>
+                <a:latin typeface="Yu Gothic" pitchFamily="34" charset="0"/>
+                <a:ea typeface="Yu Gothic" pitchFamily="34" charset="-122"/>
+                <a:cs typeface="Yu Gothic" pitchFamily="34" charset="-120"/>
+              </a:rPr>
+              <a:t>名前の由来: 「ルミ」は ルミナス(luminous)=光る から。光で浮かぶ、星の妖精。</a:t>
+            </a:r>
+            <a:endParaRPr lang="en-US" sz="1500" dirty="0"/>
+          </a:p>
+        </p:txBody>
+      </p:sp>
+      <p:sp>
+        <p:nvSpPr>
+          <p:cNvPr id="67" name="Text 64"/>
+          <p:cNvSpPr txBox="1"/>
+          <p:nvPr/>
+        </p:nvSpPr>
+        <p:spPr>
+          <a:xfrm>
             <a:off x="731520" y="5669280"/>
             <a:ext cx="6583680" cy="548640"/>
           </a:xfrm>

</xml_diff>